<commit_message>
Perguntas em português europeu, «Ceifeira» com a grafia da Athena e acertos do M7 (#140)
«Qual» seguido de nome passa a «Qual das…» ou «Que…» (48 perguntas e duas das provas); M7-F13 com os versos 12 e 14 da Athena (1924); aquecimento da M7-U2 fixo em 10 minutos; pesos do M7 no mapa (U3 25 %, prova escrita 30 %). Camada literal lingua-pessoa-m7, a mais recente.

Co-Authored-By: Claude Opus 5.5 <noreply@anthropic.com>
Claude-Session: https://claude.ai/code/session_019kk5YG7rVg4NAnh75qeMqa
</commit_message>
<xml_diff>
--- a/m7/diapositivos/sessao-03-m7-f13.pptx
+++ b/m7/diapositivos/sessao-03-m7-f13.pptx
@@ -4110,7 +4110,7 @@
                 <a:ea typeface="Arial" pitchFamily="34" charset="-122"/>
                 <a:cs typeface="Arial" pitchFamily="34" charset="-120"/>
               </a:rPr>
-              <a:t>Poesias</a:t>
+              <a:t>Athena</a:t>
             </a:r>
             <a:pPr indent="0" marL="0">
               <a:buNone/>
@@ -4124,7 +4124,7 @@
                 <a:ea typeface="Arial" pitchFamily="34" charset="-122"/>
                 <a:cs typeface="Arial" pitchFamily="34" charset="-120"/>
               </a:rPr>
-              <a:t>, Ática, 1942, Arquivo Pessoa</a:t>
+              <a:t>, n.º 3, 1924 (grafia atualizada)</a:t>
             </a:r>
             <a:endParaRPr lang="en-US" sz="1200" dirty="0"/>
           </a:p>
@@ -4463,7 +4463,7 @@
                 <a:ea typeface="Georgia" pitchFamily="34" charset="-122"/>
                 <a:cs typeface="Georgia" pitchFamily="34" charset="-120"/>
               </a:rPr>
-              <a:t>Mais razões para cantar que a vida.</a:t>
+              <a:t>Mais razões p'ra cantar que a vida.</a:t>
             </a:r>
             <a:endParaRPr lang="en-US" sz="2600" dirty="0"/>
           </a:p>
@@ -4523,7 +4523,7 @@
                 <a:ea typeface="Georgia" pitchFamily="34" charset="-122"/>
                 <a:cs typeface="Georgia" pitchFamily="34" charset="-120"/>
               </a:rPr>
-              <a:t>O que em mim sente está pensando.</a:t>
+              <a:t>O que em mim sente 'stá pensando.</a:t>
             </a:r>
             <a:endParaRPr lang="en-US" sz="2600" dirty="0"/>
           </a:p>
@@ -4618,7 +4618,7 @@
                 <a:ea typeface="Arial" pitchFamily="34" charset="-122"/>
                 <a:cs typeface="Arial" pitchFamily="34" charset="-120"/>
               </a:rPr>
-              <a:t>Poesias</a:t>
+              <a:t>Athena</a:t>
             </a:r>
             <a:pPr indent="0" marL="0">
               <a:buNone/>
@@ -4632,7 +4632,7 @@
                 <a:ea typeface="Arial" pitchFamily="34" charset="-122"/>
                 <a:cs typeface="Arial" pitchFamily="34" charset="-120"/>
               </a:rPr>
-              <a:t>, Ática, 1942, Arquivo Pessoa</a:t>
+              <a:t>, n.º 3, 1924 (grafia atualizada)</a:t>
             </a:r>
             <a:endParaRPr lang="en-US" sz="1200" dirty="0"/>
           </a:p>
@@ -4971,7 +4971,7 @@
                 <a:ea typeface="Georgia" pitchFamily="34" charset="-122"/>
                 <a:cs typeface="Georgia" pitchFamily="34" charset="-120"/>
               </a:rPr>
-              <a:t>Ó campo! Ó canção! A ciência</a:t>
+              <a:t>Ó campo! ó canção! A ciência</a:t>
             </a:r>
             <a:endParaRPr lang="en-US" sz="2600" dirty="0"/>
           </a:p>
@@ -5126,7 +5126,7 @@
                 <a:ea typeface="Arial" pitchFamily="34" charset="-122"/>
                 <a:cs typeface="Arial" pitchFamily="34" charset="-120"/>
               </a:rPr>
-              <a:t>Poesias</a:t>
+              <a:t>Athena</a:t>
             </a:r>
             <a:pPr indent="0" marL="0">
               <a:buNone/>
@@ -5140,7 +5140,7 @@
                 <a:ea typeface="Arial" pitchFamily="34" charset="-122"/>
                 <a:cs typeface="Arial" pitchFamily="34" charset="-120"/>
               </a:rPr>
-              <a:t>, Ática, 1942, Arquivo Pessoa</a:t>
+              <a:t>, n.º 3, 1924 (grafia atualizada)</a:t>
             </a:r>
             <a:endParaRPr lang="en-US" sz="1200" dirty="0"/>
           </a:p>
@@ -6546,7 +6546,7 @@
                           <a:ea typeface="Arial" pitchFamily="34" charset="-122"/>
                           <a:cs typeface="Arial" pitchFamily="34" charset="-120"/>
                         </a:rPr>
-                        <a:t>«Ó céu! / Ó campo! Ó canção!»</a:t>
+                        <a:t>«Ó céu! / Ó campo! ó canção!»</a:t>
                       </a:r>
                       <a:endParaRPr lang="en-US" sz="1800" dirty="0">
                         <a:latin typeface="Arial" charset="0"/>
@@ -6698,7 +6698,7 @@
                           <a:ea typeface="Arial" pitchFamily="34" charset="-122"/>
                           <a:cs typeface="Arial" pitchFamily="34" charset="-120"/>
                         </a:rPr>
-                        <a:t>«E canta como se tivesse / Mais razões para cantar que a vida»</a:t>
+                        <a:t>«E canta como se tivesse / Mais razões p'ra cantar que a vida»</a:t>
                       </a:r>
                       <a:endParaRPr lang="en-US" sz="1800" dirty="0">
                         <a:latin typeface="Arial" charset="0"/>

</xml_diff>

<commit_message>
M7-F13: «Ó campo! Ó canção!» volta à maiúscula, por decisão do docente
O verso 20 da «Ceifeira» deixa a minúscula da Athena e fica «Ó campo! Ó canção!» na lição, no painel, em «Ler a fundo»,
em «Quatro vozes, um problema», no arquivo do índice e nos diapositivos da sessão 3 (PDF refeito, 12 páginas). As cinco
trocas saem da camada literal lingua-pessoa-m7 (68 trocas em 42 ficheiros) e o manifesto regenera-se; a nota diz porquê.

Co-Authored-By: Claude Opus 5.5 <noreply@anthropic.com>
Claude-Session: https://claude.ai/code/session_019kk5YG7rVg4NAnh75qeMqa
</commit_message>
<xml_diff>
--- a/m7/diapositivos/sessao-03-m7-f13.pptx
+++ b/m7/diapositivos/sessao-03-m7-f13.pptx
@@ -4971,7 +4971,7 @@
                 <a:ea typeface="Georgia" pitchFamily="34" charset="-122"/>
                 <a:cs typeface="Georgia" pitchFamily="34" charset="-120"/>
               </a:rPr>
-              <a:t>Ó campo! ó canção! A ciência</a:t>
+              <a:t>Ó campo! Ó canção! A ciência</a:t>
             </a:r>
             <a:endParaRPr lang="en-US" sz="2600" dirty="0"/>
           </a:p>
@@ -6546,7 +6546,7 @@
                           <a:ea typeface="Arial" pitchFamily="34" charset="-122"/>
                           <a:cs typeface="Arial" pitchFamily="34" charset="-120"/>
                         </a:rPr>
-                        <a:t>«Ó céu! / Ó campo! ó canção!»</a:t>
+                        <a:t>«Ó céu! / Ó campo! Ó canção!»</a:t>
                       </a:r>
                       <a:endParaRPr lang="en-US" sz="1800" dirty="0">
                         <a:latin typeface="Arial" charset="0"/>

</xml_diff>

<commit_message>
M7-F13: «Ó campo! Ó canção!» volta à maiúscula (#141)
Decisão do docente de 30/10/2026: o verso 20 fica com maiúscula; as cinco trocas saem da camada lingua-pessoa-m7 (68 trocas) e os diapositivos da sessão 3 do M7 voltam a «Ó canção».

Co-Authored-By: Claude Opus 5.5 <noreply@anthropic.com>
Claude-Session: https://claude.ai/code/session_019kk5YG7rVg4NAnh75qeMqa
</commit_message>
<xml_diff>
--- a/m7/diapositivos/sessao-03-m7-f13.pptx
+++ b/m7/diapositivos/sessao-03-m7-f13.pptx
@@ -4971,7 +4971,7 @@
                 <a:ea typeface="Georgia" pitchFamily="34" charset="-122"/>
                 <a:cs typeface="Georgia" pitchFamily="34" charset="-120"/>
               </a:rPr>
-              <a:t>Ó campo! ó canção! A ciência</a:t>
+              <a:t>Ó campo! Ó canção! A ciência</a:t>
             </a:r>
             <a:endParaRPr lang="en-US" sz="2600" dirty="0"/>
           </a:p>
@@ -6546,7 +6546,7 @@
                           <a:ea typeface="Arial" pitchFamily="34" charset="-122"/>
                           <a:cs typeface="Arial" pitchFamily="34" charset="-120"/>
                         </a:rPr>
-                        <a:t>«Ó céu! / Ó campo! ó canção!»</a:t>
+                        <a:t>«Ó céu! / Ó campo! Ó canção!»</a:t>
                       </a:r>
                       <a:endParaRPr lang="en-US" sz="1800" dirty="0">
                         <a:latin typeface="Arial" charset="0"/>

</xml_diff>